<commit_message>
Bake live Colab link into slides, handout, email, run sheet, README
</commit_message>
<xml_diff>
--- a/open-source-version/INTCEC2026_workshop_slides.pptx
+++ b/open-source-version/INTCEC2026_workshop_slides.pptx
@@ -690,7 +690,7 @@
           <a:p>
             <a:r>
               <a:rPr lang="en-US" dirty="0"/>
-              <a:t>Keep this slide up during the transition. The bit.ly link is a placeholder — create the real short link to your Colab notebook and update this slide and the handout before the conference.</a:t>
+              <a:t>Keep this slide up during the transition. The Colab link is live via the GitHub repo (README has the one-click badge). An optional bit.ly of it makes typing from the projector easier.</a:t>
             </a:r>
             <a:endParaRPr lang="en-US" dirty="0"/>
           </a:p>
@@ -2880,7 +2880,7 @@
                 <a:ea typeface="Calibri" pitchFamily="34" charset="-122"/>
                 <a:cs typeface="Calibri" pitchFamily="34" charset="-120"/>
               </a:rPr>
-              <a:t>bit.ly/intcec26-agents   (Colab — any browser, Google account)</a:t>
+              <a:t>github.com/harunpirim/intcec2026-agentic-ai-workshop → “Open the notebook in Colab”</a:t>
             </a:r>
             <a:endParaRPr lang="en-US" sz="1500" dirty="0"/>
           </a:p>

</xml_diff>